<commit_message>
feat(stackup): Lithium-inspired Physical PCB Stack-up — 7 пресетов
Аналог Lithium ECAD Stacks/_*Core.lt — физическая модель платы с толщинами
меди, prepreg, core. Используется для расчёта импеданса трасс, теплового
анализа, 3D-визуализации с реалистичной толщиной, production-документации.

Что добавлено:
- window.PCB_STACKUPS — 5 заполненных пресетов (2/4/6 Core, 4 Foil) + skeleton 8-Core
- openStackupDialog() — модал с превью каждого стека (цветные полосы пропорц. толщине)
- Hamburger ☰ → новая секция «📚 Стек слоёв PCB» с кнопкой настройки
- Сохраняется в currentProject.stackup_id

Превью стека (2-Core):
  Top Copper    18µm   Copper
  FR-4 Core    1500µm  FR-4 ε=4.5
  Bottom Copper 18µm   Copper
  Σ 1.536мм

Cache-bump: ?v=20260602-stackup.

Co-Authored-By: Claude Opus 4.7 <noreply@anthropic.com>
</commit_message>
<xml_diff>
--- a/docs/Презентация_DOLG_основная_защита_20_слайдов_20260602.pptx
+++ b/docs/Презентация_DOLG_основная_защита_20_слайдов_20260602.pptx
@@ -9864,15 +9864,194 @@
               </a:lnSpc>
             </a:pPr>
             <a:r>
-              <a:rPr sz="2900" b="0">
-                <a:solidFill>
-                  <a:srgbClr val="1E293B"/>
-                </a:solidFill>
-                <a:latin typeface="Arial"/>
-              </a:rPr>
-              <a:t>• комментарии пользователей</a:t>
-            </a:r>
-          </a:p>
+              <a:rPr sz="2200" b="0">
+                <a:solidFill>
+                  <a:srgbClr val="122340"/>
+                </a:solidFill>
+                <a:latin typeface="Arial"/>
+              </a:rPr>
+              <a:t>• комментарии и модерация</a:t>
+            </a:r>
+          </a:p>
+          <a:p>
+            <a:r>
+              <a:rPr sz="2200" b="0">
+                <a:solidFill>
+                  <a:srgbClr val="122340"/>
+                </a:solidFill>
+                <a:latin typeface="Arial"/>
+              </a:rPr>
+              <a:t>• measurement core</a:t>
+            </a:r>
+          </a:p>
+          <a:p>
+            <a:r>
+              <a:rPr sz="2200" b="0">
+                <a:solidFill>
+                  <a:srgbClr val="122340"/>
+                </a:solidFill>
+                <a:latin typeface="Arial"/>
+              </a:rPr>
+              <a:t>• official image/API sources</a:t>
+            </a:r>
+          </a:p>
+          <a:p>
+            <a:r>
+              <a:rPr sz="2200" b="0">
+                <a:solidFill>
+                  <a:srgbClr val="122340"/>
+                </a:solidFill>
+                <a:latin typeface="Arial"/>
+              </a:rPr>
+              <a:t>• datasheet extraction</a:t>
+            </a:r>
+          </a:p>
+        </p:txBody>
+      </p:sp>
+      <p:sp>
+        <p:nvSpPr>
+          <p:cNvPr id="11" name="Rectangle 10"/>
+          <p:cNvSpPr/>
+          <p:nvPr/>
+        </p:nvSpPr>
+        <p:spPr>
+          <a:xfrm>
+            <a:off x="7680960" y="1417320"/>
+            <a:ext cx="6217920" cy="5166360"/>
+          </a:xfrm>
+          <a:prstGeom prst="rect">
+            <a:avLst/>
+          </a:prstGeom>
+          <a:solidFill>
+            <a:srgbClr val="EEF3F8"/>
+          </a:solidFill>
+          <a:ln w="15875">
+            <a:solidFill>
+              <a:srgbClr val="94A3B8"/>
+            </a:solidFill>
+          </a:ln>
+        </p:spPr>
+        <p:style>
+          <a:lnRef idx="1">
+            <a:schemeClr val="accent1"/>
+          </a:lnRef>
+          <a:fillRef idx="3">
+            <a:schemeClr val="accent1"/>
+          </a:fillRef>
+          <a:effectRef idx="2">
+            <a:schemeClr val="accent1"/>
+          </a:effectRef>
+          <a:fontRef idx="minor">
+            <a:schemeClr val="lt1"/>
+          </a:fontRef>
+        </p:style>
+        <p:txBody>
+          <a:bodyPr rtlCol="0" anchor="ctr"/>
+          <a:lstStyle/>
+          <a:p>
+            <a:pPr algn="ctr"/>
+          </a:p>
+        </p:txBody>
+      </p:sp>
+      <p:sp>
+        <p:nvSpPr>
+          <p:cNvPr id="12" name="Rectangle 11"/>
+          <p:cNvSpPr/>
+          <p:nvPr/>
+        </p:nvSpPr>
+        <p:spPr>
+          <a:xfrm>
+            <a:off x="7680960" y="1417320"/>
+            <a:ext cx="6217920" cy="109728"/>
+          </a:xfrm>
+          <a:prstGeom prst="rect">
+            <a:avLst/>
+          </a:prstGeom>
+          <a:solidFill>
+            <a:srgbClr val="7C3AED"/>
+          </a:solidFill>
+          <a:ln>
+            <a:noFill/>
+          </a:ln>
+        </p:spPr>
+        <p:style>
+          <a:lnRef idx="1">
+            <a:schemeClr val="accent1"/>
+          </a:lnRef>
+          <a:fillRef idx="3">
+            <a:schemeClr val="accent1"/>
+          </a:fillRef>
+          <a:effectRef idx="2">
+            <a:schemeClr val="accent1"/>
+          </a:effectRef>
+          <a:fontRef idx="minor">
+            <a:schemeClr val="lt1"/>
+          </a:fontRef>
+        </p:style>
+        <p:txBody>
+          <a:bodyPr rtlCol="0" anchor="ctr"/>
+          <a:lstStyle/>
+          <a:p>
+            <a:pPr algn="ctr"/>
+          </a:p>
+        </p:txBody>
+      </p:sp>
+      <p:sp>
+        <p:nvSpPr>
+          <p:cNvPr id="13" name="TextBox 12"/>
+          <p:cNvSpPr txBox="1"/>
+          <p:nvPr/>
+        </p:nvSpPr>
+        <p:spPr>
+          <a:xfrm>
+            <a:off x="7845552" y="1581912"/>
+            <a:ext cx="5888736" cy="694944"/>
+          </a:xfrm>
+          <a:prstGeom prst="rect">
+            <a:avLst/>
+          </a:prstGeom>
+          <a:noFill/>
+        </p:spPr>
+        <p:txBody>
+          <a:bodyPr wrap="square" anchor="t" lIns="9144" rIns="9144" tIns="9144" bIns="9144">
+            <a:normAutofit/>
+          </a:bodyPr>
+          <a:lstStyle/>
+          <a:p>
+            <a:pPr algn="l"/>
+            <a:r>
+              <a:rPr sz="2600" b="1">
+                <a:solidFill>
+                  <a:srgbClr val="0F172A"/>
+                </a:solidFill>
+                <a:latin typeface="Arial"/>
+              </a:rPr>
+              <a:t>Дальнейшее</a:t>
+            </a:r>
+          </a:p>
+        </p:txBody>
+      </p:sp>
+      <p:sp>
+        <p:nvSpPr>
+          <p:cNvPr id="14" name="TextBox 13"/>
+          <p:cNvSpPr txBox="1"/>
+          <p:nvPr/>
+        </p:nvSpPr>
+        <p:spPr>
+          <a:xfrm>
+            <a:off x="7845552" y="2203704"/>
+            <a:ext cx="5888736" cy="4325112"/>
+          </a:xfrm>
+          <a:prstGeom prst="rect">
+            <a:avLst/>
+          </a:prstGeom>
+          <a:noFill/>
+        </p:spPr>
+        <p:txBody>
+          <a:bodyPr wrap="square" anchor="t" lIns="9144" rIns="9144" tIns="9144" bIns="9144">
+            <a:normAutofit/>
+          </a:bodyPr>
+          <a:lstStyle/>
           <a:p>
             <a:pPr algn="l">
               <a:lnSpc>
@@ -9880,207 +10059,13 @@
               </a:lnSpc>
             </a:pPr>
             <a:r>
-              <a:rPr sz="2900" b="0">
-                <a:solidFill>
-                  <a:srgbClr val="1E293B"/>
-                </a:solidFill>
-                <a:latin typeface="Arial"/>
-              </a:rPr>
-              <a:t>• measurement core</a:t>
-            </a:r>
-          </a:p>
-          <a:p>
-            <a:pPr algn="l">
-              <a:lnSpc>
-                <a:spcPct val="92000"/>
-              </a:lnSpc>
-            </a:pPr>
-            <a:r>
-              <a:rPr sz="2900" b="0">
-                <a:solidFill>
-                  <a:srgbClr val="1E293B"/>
-                </a:solidFill>
-                <a:latin typeface="Arial"/>
-              </a:rPr>
-              <a:t>• official image/API sources</a:t>
-            </a:r>
-          </a:p>
-          <a:p>
-            <a:pPr algn="l">
-              <a:lnSpc>
-                <a:spcPct val="92000"/>
-              </a:lnSpc>
-            </a:pPr>
-            <a:r>
-              <a:rPr sz="2900" b="0">
-                <a:solidFill>
-                  <a:srgbClr val="1E293B"/>
-                </a:solidFill>
-                <a:latin typeface="Arial"/>
-              </a:rPr>
-              <a:t>• datasheet extraction</a:t>
-            </a:r>
-          </a:p>
-        </p:txBody>
-      </p:sp>
-      <p:sp>
-        <p:nvSpPr>
-          <p:cNvPr id="11" name="Rectangle 10"/>
-          <p:cNvSpPr/>
-          <p:nvPr/>
-        </p:nvSpPr>
-        <p:spPr>
-          <a:xfrm>
-            <a:off x="7680960" y="1417320"/>
-            <a:ext cx="6217920" cy="5166360"/>
-          </a:xfrm>
-          <a:prstGeom prst="rect">
-            <a:avLst/>
-          </a:prstGeom>
-          <a:solidFill>
-            <a:srgbClr val="EEF3F8"/>
-          </a:solidFill>
-          <a:ln w="15875">
-            <a:solidFill>
-              <a:srgbClr val="94A3B8"/>
-            </a:solidFill>
-          </a:ln>
-        </p:spPr>
-        <p:style>
-          <a:lnRef idx="1">
-            <a:schemeClr val="accent1"/>
-          </a:lnRef>
-          <a:fillRef idx="3">
-            <a:schemeClr val="accent1"/>
-          </a:fillRef>
-          <a:effectRef idx="2">
-            <a:schemeClr val="accent1"/>
-          </a:effectRef>
-          <a:fontRef idx="minor">
-            <a:schemeClr val="lt1"/>
-          </a:fontRef>
-        </p:style>
-        <p:txBody>
-          <a:bodyPr rtlCol="0" anchor="ctr"/>
-          <a:lstStyle/>
-          <a:p>
-            <a:pPr algn="ctr"/>
-          </a:p>
-        </p:txBody>
-      </p:sp>
-      <p:sp>
-        <p:nvSpPr>
-          <p:cNvPr id="12" name="Rectangle 11"/>
-          <p:cNvSpPr/>
-          <p:nvPr/>
-        </p:nvSpPr>
-        <p:spPr>
-          <a:xfrm>
-            <a:off x="7680960" y="1417320"/>
-            <a:ext cx="6217920" cy="109728"/>
-          </a:xfrm>
-          <a:prstGeom prst="rect">
-            <a:avLst/>
-          </a:prstGeom>
-          <a:solidFill>
-            <a:srgbClr val="7C3AED"/>
-          </a:solidFill>
-          <a:ln>
-            <a:noFill/>
-          </a:ln>
-        </p:spPr>
-        <p:style>
-          <a:lnRef idx="1">
-            <a:schemeClr val="accent1"/>
-          </a:lnRef>
-          <a:fillRef idx="3">
-            <a:schemeClr val="accent1"/>
-          </a:fillRef>
-          <a:effectRef idx="2">
-            <a:schemeClr val="accent1"/>
-          </a:effectRef>
-          <a:fontRef idx="minor">
-            <a:schemeClr val="lt1"/>
-          </a:fontRef>
-        </p:style>
-        <p:txBody>
-          <a:bodyPr rtlCol="0" anchor="ctr"/>
-          <a:lstStyle/>
-          <a:p>
-            <a:pPr algn="ctr"/>
-          </a:p>
-        </p:txBody>
-      </p:sp>
-      <p:sp>
-        <p:nvSpPr>
-          <p:cNvPr id="13" name="TextBox 12"/>
-          <p:cNvSpPr txBox="1"/>
-          <p:nvPr/>
-        </p:nvSpPr>
-        <p:spPr>
-          <a:xfrm>
-            <a:off x="7845552" y="1581912"/>
-            <a:ext cx="5888736" cy="694944"/>
-          </a:xfrm>
-          <a:prstGeom prst="rect">
-            <a:avLst/>
-          </a:prstGeom>
-          <a:noFill/>
-        </p:spPr>
-        <p:txBody>
-          <a:bodyPr wrap="square" anchor="t" lIns="9144" rIns="9144" tIns="9144" bIns="9144">
-            <a:normAutofit/>
-          </a:bodyPr>
-          <a:lstStyle/>
-          <a:p>
-            <a:pPr algn="l"/>
-            <a:r>
-              <a:rPr sz="2600" b="1">
-                <a:solidFill>
-                  <a:srgbClr val="0F172A"/>
-                </a:solidFill>
-                <a:latin typeface="Arial"/>
-              </a:rPr>
-              <a:t>Дальнейшее</a:t>
-            </a:r>
-          </a:p>
-        </p:txBody>
-      </p:sp>
-      <p:sp>
-        <p:nvSpPr>
-          <p:cNvPr id="14" name="TextBox 13"/>
-          <p:cNvSpPr txBox="1"/>
-          <p:nvPr/>
-        </p:nvSpPr>
-        <p:spPr>
-          <a:xfrm>
-            <a:off x="7845552" y="2203704"/>
-            <a:ext cx="5888736" cy="4325112"/>
-          </a:xfrm>
-          <a:prstGeom prst="rect">
-            <a:avLst/>
-          </a:prstGeom>
-          <a:noFill/>
-        </p:spPr>
-        <p:txBody>
-          <a:bodyPr wrap="square" anchor="t" lIns="9144" rIns="9144" tIns="9144" bIns="9144">
-            <a:normAutofit/>
-          </a:bodyPr>
-          <a:lstStyle/>
-          <a:p>
-            <a:pPr algn="l">
-              <a:lnSpc>
-                <a:spcPct val="92000"/>
-              </a:lnSpc>
-            </a:pPr>
-            <a:r>
               <a:rPr sz="2200" b="0">
                 <a:solidFill>
                   <a:srgbClr val="122340"/>
                 </a:solidFill>
                 <a:latin typeface="Arial"/>
               </a:rPr>
-              <a:t>? ?????? ????? 1?10</a:t>
+              <a:t>• уровни цепей 1–10</a:t>
             </a:r>
           </a:p>
           <a:p>
@@ -10091,7 +10076,7 @@
                 </a:solidFill>
                 <a:latin typeface="Arial"/>
               </a:rPr>
-              <a:t>? cross-highlight CAD?3D</a:t>
+              <a:t>• cross-highlight CAD↔3D</a:t>
             </a:r>
           </a:p>
           <a:p>
@@ -10102,7 +10087,7 @@
                 </a:solidFill>
                 <a:latin typeface="Arial"/>
               </a:rPr>
-              <a:t>? ?????????????? ????? ????</a:t>
+              <a:t>• функциональные блоки схем</a:t>
             </a:r>
           </a:p>
           <a:p>
@@ -10113,7 +10098,7 @@
                 </a:solidFill>
                 <a:latin typeface="Arial"/>
               </a:rPr>
-              <a:t>? OR-Tools / RDFLib / neural hints</a:t>
+              <a:t>• OR-Tools / RDFLib / neural hints</a:t>
             </a:r>
           </a:p>
         </p:txBody>
@@ -12277,15 +12262,8 @@
           </a:bodyPr>
           <a:lstStyle/>
           <a:p>
-            <a:pPr algn="ctr"/>
-            <a:r>
-              <a:rPr sz="1850" b="1">
-                <a:solidFill>
-                  <a:srgbClr val="1E293B"/>
-                </a:solidFill>
-                <a:latin typeface="Arial"/>
-              </a:rPr>
-              <a:t>статья</a:t>
+            <a:r>
+              <a:t>статьи</a:t>
             </a:r>
           </a:p>
         </p:txBody>
@@ -12982,7 +12960,7 @@
                 </a:solidFill>
                 <a:latin typeface="Arial"/>
               </a:rPr>
-              <a:t>? manage.py check</a:t>
+              <a:t>• manage.py check</a:t>
             </a:r>
           </a:p>
           <a:p>
@@ -12993,7 +12971,7 @@
                 </a:solidFill>
                 <a:latin typeface="Arial"/>
               </a:rPr>
-              <a:t>? check_demo_ready</a:t>
+              <a:t>• check_demo_ready</a:t>
             </a:r>
           </a:p>
           <a:p>
@@ -13004,7 +12982,7 @@
                 </a:solidFill>
                 <a:latin typeface="Arial"/>
               </a:rPr>
-              <a:t>? check_data_integrity</a:t>
+              <a:t>• check_data_integrity</a:t>
             </a:r>
           </a:p>
           <a:p>
@@ -13015,7 +12993,7 @@
                 </a:solidFill>
                 <a:latin typeface="Arial"/>
               </a:rPr>
-              <a:t>? media quality 364/364</a:t>
+              <a:t>• media quality 364/364</a:t>
             </a:r>
           </a:p>
         </p:txBody>
@@ -15091,7 +15069,7 @@
                 </a:solidFill>
                 <a:latin typeface="Arial"/>
               </a:rPr>
-              <a:t>????????????</a:t>
+              <a:t>Маркетплейсы</a:t>
             </a:r>
           </a:p>
           <a:p>
@@ -15102,7 +15080,7 @@
                 </a:solidFill>
                 <a:latin typeface="Arial"/>
               </a:rPr>
-              <a:t>?????? ? ???????, ?? ?? ????????? ?????</a:t>
+              <a:t>сильны в продаже, но не проверяют схему</a:t>
             </a:r>
           </a:p>
         </p:txBody>
@@ -15167,7 +15145,7 @@
                 </a:solidFill>
                 <a:latin typeface="Arial"/>
               </a:rPr>
-              <a:t>???? ?????????????, ?? ????? ??????? ? ???????</a:t>
+              <a:t>дают моделирование, но слабо связаны с заказом</a:t>
             </a:r>
           </a:p>
         </p:txBody>
@@ -15232,7 +15210,7 @@
                 </a:solidFill>
                 <a:latin typeface="Arial"/>
               </a:rPr>
-              <a:t>???????????? CAD, ?? ???????? ?? ????????</a:t>
+              <a:t>промышленный CAD, но отдельно от магазина</a:t>
             </a:r>
           </a:p>
         </p:txBody>
@@ -15297,7 +15275,7 @@
                 </a:solidFill>
                 <a:latin typeface="Arial"/>
               </a:rPr>
-              <a:t>?????????????, ?????? ?????, ?????????????? ?????</a:t>
+              <a:t>синхронизация, уровни цепей, функциональные блоки</a:t>
             </a:r>
           </a:p>
         </p:txBody>
@@ -15351,7 +15329,7 @@
                 </a:solidFill>
                 <a:latin typeface="Arial"/>
               </a:rPr>
-              <a:t>???? DOLG: ????????? ? ?????? ? ????? ? ????????? ? review ? BOM ? ?????</a:t>
+              <a:t>Ниша DOLG: компонент → расчет → схема → симуляция → review → BOM → заказ</a:t>
             </a:r>
           </a:p>
         </p:txBody>
@@ -20006,7 +19984,7 @@
                 </a:solidFill>
                 <a:latin typeface="Arial"/>
               </a:rPr>
-              <a:t>? 364 ???????? ???????</a:t>
+              <a:t>• 364 карточки товаров</a:t>
             </a:r>
           </a:p>
           <a:p>
@@ -20017,7 +19995,7 @@
                 </a:solidFill>
                 <a:latin typeface="Arial"/>
               </a:rPr>
-              <a:t>? 227 ???-???????????</a:t>
+              <a:t>• 227 РЭБ-компонентов</a:t>
             </a:r>
           </a:p>
           <a:p>
@@ -20028,7 +20006,7 @@
                 </a:solidFill>
                 <a:latin typeface="Arial"/>
               </a:rPr>
-              <a:t>? ???????? chips ? ???????</a:t>
+              <a:t>• активные chips → фильтры</a:t>
             </a:r>
           </a:p>
           <a:p>
@@ -20039,7 +20017,7 @@
                 </a:solidFill>
                 <a:latin typeface="Arial"/>
               </a:rPr>
-              <a:t>? unit-aware ?????</a:t>
+              <a:t>• unit-aware поиск</a:t>
             </a:r>
           </a:p>
           <a:p>
@@ -20050,7 +20028,7 @@
                 </a:solidFill>
                 <a:latin typeface="Arial"/>
               </a:rPr>
-              <a:t>? 79 verified photos; media quality OK</a:t>
+              <a:t>• 79 verified photos; media quality OK</a:t>
             </a:r>
           </a:p>
         </p:txBody>
@@ -20444,15 +20422,8 @@
           </a:bodyPr>
           <a:lstStyle/>
           <a:p>
-            <a:pPr algn="ctr"/>
-            <a:r>
-              <a:rPr sz="1900" b="0">
-                <a:solidFill>
-                  <a:srgbClr val="1E293B"/>
-                </a:solidFill>
-                <a:latin typeface="Arial"/>
-              </a:rPr>
-              <a:t>статья</a:t>
+            <a:r>
+              <a:t>статьи</a:t>
             </a:r>
           </a:p>
         </p:txBody>
@@ -20595,15 +20566,8 @@
           </a:bodyPr>
           <a:lstStyle/>
           <a:p>
-            <a:pPr algn="ctr"/>
-            <a:r>
-              <a:rPr sz="1650" b="0">
-                <a:solidFill>
-                  <a:srgbClr val="1E293B"/>
-                </a:solidFill>
-                <a:latin typeface="Arial"/>
-              </a:rPr>
-              <a:t>материалы</a:t>
+            <a:r>
+              <a:t>материалов</a:t>
             </a:r>
           </a:p>
         </p:txBody>
@@ -20746,15 +20710,8 @@
           </a:bodyPr>
           <a:lstStyle/>
           <a:p>
-            <a:pPr algn="ctr"/>
-            <a:r>
-              <a:rPr sz="1900" b="0">
-                <a:solidFill>
-                  <a:srgbClr val="1E293B"/>
-                </a:solidFill>
-                <a:latin typeface="Arial"/>
-              </a:rPr>
-              <a:t>задания</a:t>
+            <a:r>
+              <a:t>заданий</a:t>
             </a:r>
           </a:p>
         </p:txBody>

</xml_diff>